<commit_message>
Add Group 12 cover and section headers to presentation
</commit_message>
<xml_diff>
--- a/Group12_DAA_Macro_Project.pptx
+++ b/Group12_DAA_Macro_Project.pptx
@@ -6,6 +6,7 @@
     <p:sldMasterId id="2147483660" r:id="rId2"/>
   </p:sldMasterIdLst>
   <p:sldIdLst>
+    <p:sldId id="291" r:id="rId42"/>
     <p:sldId id="256" r:id="rId3"/>
     <p:sldId id="257" r:id="rId4"/>
     <p:sldId id="258" r:id="rId5"/>
@@ -2020,7 +2021,7 @@
               </a:defRPr>
             </a:pPr>
             <a:r>
-              <a:t>B.Tech CSE — Mini Project Presentation</a:t>
+              <a:t>B.Tech CSE — Group 12 | Mini Project Presentation</a:t>
             </a:r>
           </a:p>
         </p:txBody>
@@ -2576,7 +2577,7 @@
               </a:defRPr>
             </a:pPr>
             <a:r>
-              <a:t>Design and Analysis of Algorithms — DAA-538</a:t>
+              <a:t>Design and Analysis of Algorithms — Group 12</a:t>
             </a:r>
           </a:p>
         </p:txBody>
@@ -5996,6 +5997,42 @@
           </a:p>
         </p:txBody>
       </p:sp>
+      <p:sp>
+        <p:nvSpPr>
+          <p:cNvPr id="3" name="TextBox 2"/>
+          <p:cNvSpPr txBox="1"/>
+          <p:nvPr/>
+        </p:nvSpPr>
+        <p:spPr>
+          <a:xfrm>
+            <a:off x="914400" y="3291840"/>
+            <a:ext cx="10332720" cy="731520"/>
+          </a:xfrm>
+          <a:prstGeom prst="rect">
+            <a:avLst/>
+          </a:prstGeom>
+          <a:noFill/>
+        </p:spPr>
+        <p:txBody>
+          <a:bodyPr wrap="none">
+            <a:spAutoFit/>
+          </a:bodyPr>
+          <a:lstStyle/>
+          <a:p>
+            <a:pPr algn="ctr">
+              <a:defRPr sz="2200" b="1">
+                <a:solidFill>
+                  <a:srgbClr val="1A237E"/>
+                </a:solidFill>
+                <a:latin typeface="Calibri"/>
+              </a:defRPr>
+            </a:pPr>
+            <a:r>
+              <a:t>DAA Macro Project — Group 12</a:t>
+            </a:r>
+          </a:p>
+        </p:txBody>
+      </p:sp>
     </p:spTree>
   </p:cSld>
   <p:clrMapOvr>
@@ -7056,7 +7093,7 @@
               </a:defRPr>
             </a:pPr>
             <a:r>
-              <a:t>Design and Analysis of Algorithms (DAA)</a:t>
+              <a:t>Design and Analysis of Algorithms (DAA) — Group 12</a:t>
             </a:r>
           </a:p>
         </p:txBody>
@@ -11307,6 +11344,670 @@
             </a:pPr>
             <a:r>
               <a:t>10/10</a:t>
+            </a:r>
+          </a:p>
+        </p:txBody>
+      </p:sp>
+    </p:spTree>
+  </p:cSld>
+  <p:clrMapOvr>
+    <a:masterClrMapping/>
+  </p:clrMapOvr>
+</p:sld>
+</file>
+
+<file path=ppt/slides/slide36.xml><?xml version="1.0" encoding="utf-8"?>
+<p:sld xmlns:a="http://schemas.openxmlformats.org/drawingml/2006/main" xmlns:p="http://schemas.openxmlformats.org/presentationml/2006/main" xmlns:r="http://schemas.openxmlformats.org/officeDocument/2006/relationships">
+  <p:cSld>
+    <p:spTree>
+      <p:nvGrpSpPr>
+        <p:cNvPr id="1" name=""/>
+        <p:cNvGrpSpPr/>
+        <p:nvPr/>
+      </p:nvGrpSpPr>
+      <p:grpSpPr/>
+      <p:sp>
+        <p:nvSpPr>
+          <p:cNvPr id="2" name="Rectangle 1"/>
+          <p:cNvSpPr/>
+          <p:nvPr/>
+        </p:nvSpPr>
+        <p:spPr>
+          <a:xfrm>
+            <a:off x="0" y="0"/>
+            <a:ext cx="12192000" cy="6858000"/>
+          </a:xfrm>
+          <a:prstGeom prst="rect">
+            <a:avLst/>
+          </a:prstGeom>
+          <a:solidFill>
+            <a:srgbClr val="1A237E"/>
+          </a:solidFill>
+          <a:ln>
+            <a:noFill/>
+          </a:ln>
+        </p:spPr>
+        <p:style>
+          <a:lnRef idx="1">
+            <a:schemeClr val="accent1"/>
+          </a:lnRef>
+          <a:fillRef idx="3">
+            <a:schemeClr val="accent1"/>
+          </a:fillRef>
+          <a:effectRef idx="2">
+            <a:schemeClr val="accent1"/>
+          </a:effectRef>
+          <a:fontRef idx="minor">
+            <a:schemeClr val="lt1"/>
+          </a:fontRef>
+        </p:style>
+        <p:txBody>
+          <a:bodyPr rtlCol="0" anchor="ctr"/>
+          <a:lstStyle/>
+          <a:p>
+            <a:pPr algn="ctr"/>
+          </a:p>
+        </p:txBody>
+      </p:sp>
+      <p:sp>
+        <p:nvSpPr>
+          <p:cNvPr id="3" name="Rounded Rectangle 2"/>
+          <p:cNvSpPr/>
+          <p:nvPr/>
+        </p:nvSpPr>
+        <p:spPr>
+          <a:xfrm>
+            <a:off x="4206240" y="548640"/>
+            <a:ext cx="3749039" cy="411480"/>
+          </a:xfrm>
+          <a:prstGeom prst="roundRect">
+            <a:avLst/>
+          </a:prstGeom>
+          <a:solidFill>
+            <a:srgbClr val="283593"/>
+          </a:solidFill>
+          <a:ln w="19050">
+            <a:solidFill>
+              <a:srgbClr val="64B5F6"/>
+            </a:solidFill>
+          </a:ln>
+        </p:spPr>
+        <p:style>
+          <a:lnRef idx="1">
+            <a:schemeClr val="accent1"/>
+          </a:lnRef>
+          <a:fillRef idx="3">
+            <a:schemeClr val="accent1"/>
+          </a:fillRef>
+          <a:effectRef idx="2">
+            <a:schemeClr val="accent1"/>
+          </a:effectRef>
+          <a:fontRef idx="minor">
+            <a:schemeClr val="lt1"/>
+          </a:fontRef>
+        </p:style>
+        <p:txBody>
+          <a:bodyPr rtlCol="0" anchor="ctr"/>
+          <a:lstStyle/>
+          <a:p>
+            <a:pPr algn="ctr">
+              <a:defRPr sz="1300" b="1">
+                <a:solidFill>
+                  <a:srgbClr val="64B5F6"/>
+                </a:solidFill>
+                <a:latin typeface="Calibri"/>
+              </a:defRPr>
+            </a:pPr>
+            <a:r>
+              <a:t>DESIGN AND ANALYSIS OF ALGORITHMS</a:t>
+            </a:r>
+          </a:p>
+        </p:txBody>
+      </p:sp>
+      <p:sp>
+        <p:nvSpPr>
+          <p:cNvPr id="4" name="TextBox 3"/>
+          <p:cNvSpPr txBox="1"/>
+          <p:nvPr/>
+        </p:nvSpPr>
+        <p:spPr>
+          <a:xfrm>
+            <a:off x="731520" y="1097280"/>
+            <a:ext cx="10698480" cy="1005840"/>
+          </a:xfrm>
+          <a:prstGeom prst="rect">
+            <a:avLst/>
+          </a:prstGeom>
+          <a:noFill/>
+        </p:spPr>
+        <p:txBody>
+          <a:bodyPr wrap="square">
+            <a:spAutoFit/>
+          </a:bodyPr>
+          <a:lstStyle/>
+          <a:p>
+            <a:pPr algn="ctr">
+              <a:defRPr sz="4600" b="1">
+                <a:solidFill>
+                  <a:srgbClr val="FFFFFF"/>
+                </a:solidFill>
+                <a:latin typeface="Calibri"/>
+              </a:defRPr>
+            </a:pPr>
+            <a:r>
+              <a:t>DAA MACRO PROJECT</a:t>
+            </a:r>
+          </a:p>
+        </p:txBody>
+      </p:sp>
+      <p:sp>
+        <p:nvSpPr>
+          <p:cNvPr id="5" name="Rounded Rectangle 4"/>
+          <p:cNvSpPr/>
+          <p:nvPr/>
+        </p:nvSpPr>
+        <p:spPr>
+          <a:xfrm>
+            <a:off x="3840480" y="2148840"/>
+            <a:ext cx="4480560" cy="731520"/>
+          </a:xfrm>
+          <a:prstGeom prst="roundRect">
+            <a:avLst/>
+          </a:prstGeom>
+          <a:solidFill>
+            <a:srgbClr val="FFD54F"/>
+          </a:solidFill>
+          <a:ln>
+            <a:noFill/>
+          </a:ln>
+        </p:spPr>
+        <p:style>
+          <a:lnRef idx="1">
+            <a:schemeClr val="accent1"/>
+          </a:lnRef>
+          <a:fillRef idx="3">
+            <a:schemeClr val="accent1"/>
+          </a:fillRef>
+          <a:effectRef idx="2">
+            <a:schemeClr val="accent1"/>
+          </a:effectRef>
+          <a:fontRef idx="minor">
+            <a:schemeClr val="lt1"/>
+          </a:fontRef>
+        </p:style>
+        <p:txBody>
+          <a:bodyPr rtlCol="0" anchor="ctr"/>
+          <a:lstStyle/>
+          <a:p>
+            <a:pPr algn="ctr">
+              <a:defRPr sz="2800" b="1">
+                <a:solidFill>
+                  <a:srgbClr val="1A237E"/>
+                </a:solidFill>
+                <a:latin typeface="Calibri"/>
+              </a:defRPr>
+            </a:pPr>
+            <a:r>
+              <a:t>GROUP — 12</a:t>
+            </a:r>
+          </a:p>
+        </p:txBody>
+      </p:sp>
+      <p:sp>
+        <p:nvSpPr>
+          <p:cNvPr id="6" name="TextBox 5"/>
+          <p:cNvSpPr txBox="1"/>
+          <p:nvPr/>
+        </p:nvSpPr>
+        <p:spPr>
+          <a:xfrm>
+            <a:off x="731520" y="2971800"/>
+            <a:ext cx="10698480" cy="457200"/>
+          </a:xfrm>
+          <a:prstGeom prst="rect">
+            <a:avLst/>
+          </a:prstGeom>
+          <a:noFill/>
+        </p:spPr>
+        <p:txBody>
+          <a:bodyPr wrap="none">
+            <a:spAutoFit/>
+          </a:bodyPr>
+          <a:lstStyle/>
+          <a:p>
+            <a:pPr algn="ctr">
+              <a:defRPr sz="1700">
+                <a:solidFill>
+                  <a:srgbClr val="CFD8DC"/>
+                </a:solidFill>
+                <a:latin typeface="Calibri"/>
+              </a:defRPr>
+            </a:pPr>
+            <a:r>
+              <a:t>B.Tech Computer Science &amp; Engineering — Comprehensive Unit Portfolio</a:t>
+            </a:r>
+          </a:p>
+        </p:txBody>
+      </p:sp>
+      <p:sp>
+        <p:nvSpPr>
+          <p:cNvPr id="7" name="Rectangle 6"/>
+          <p:cNvSpPr/>
+          <p:nvPr/>
+        </p:nvSpPr>
+        <p:spPr>
+          <a:xfrm>
+            <a:off x="2286000" y="3520440"/>
+            <a:ext cx="7619695" cy="27432"/>
+          </a:xfrm>
+          <a:prstGeom prst="rect">
+            <a:avLst/>
+          </a:prstGeom>
+          <a:solidFill>
+            <a:srgbClr val="64B5F6"/>
+          </a:solidFill>
+          <a:ln>
+            <a:noFill/>
+          </a:ln>
+        </p:spPr>
+        <p:style>
+          <a:lnRef idx="1">
+            <a:schemeClr val="accent1"/>
+          </a:lnRef>
+          <a:fillRef idx="3">
+            <a:schemeClr val="accent1"/>
+          </a:fillRef>
+          <a:effectRef idx="2">
+            <a:schemeClr val="accent1"/>
+          </a:effectRef>
+          <a:fontRef idx="minor">
+            <a:schemeClr val="lt1"/>
+          </a:fontRef>
+        </p:style>
+        <p:txBody>
+          <a:bodyPr rtlCol="0" anchor="ctr"/>
+          <a:lstStyle/>
+          <a:p>
+            <a:pPr algn="ctr"/>
+          </a:p>
+        </p:txBody>
+      </p:sp>
+      <p:sp>
+        <p:nvSpPr>
+          <p:cNvPr id="8" name="Rounded Rectangle 7"/>
+          <p:cNvSpPr/>
+          <p:nvPr/>
+        </p:nvSpPr>
+        <p:spPr>
+          <a:xfrm>
+            <a:off x="731520" y="3794760"/>
+            <a:ext cx="2468880" cy="2468880"/>
+          </a:xfrm>
+          <a:prstGeom prst="roundRect">
+            <a:avLst/>
+          </a:prstGeom>
+          <a:solidFill>
+            <a:srgbClr val="283593"/>
+          </a:solidFill>
+          <a:ln w="19050">
+            <a:solidFill>
+              <a:srgbClr val="64B5F6"/>
+            </a:solidFill>
+          </a:ln>
+        </p:spPr>
+        <p:style>
+          <a:lnRef idx="1">
+            <a:schemeClr val="accent1"/>
+          </a:lnRef>
+          <a:fillRef idx="3">
+            <a:schemeClr val="accent1"/>
+          </a:fillRef>
+          <a:effectRef idx="2">
+            <a:schemeClr val="accent1"/>
+          </a:effectRef>
+          <a:fontRef idx="minor">
+            <a:schemeClr val="lt1"/>
+          </a:fontRef>
+        </p:style>
+        <p:txBody>
+          <a:bodyPr rtlCol="0" anchor="ctr" wrap="square"/>
+          <a:lstStyle/>
+          <a:p>
+            <a:pPr algn="ctr">
+              <a:defRPr sz="1400" b="1">
+                <a:solidFill>
+                  <a:srgbClr val="FFD54F"/>
+                </a:solidFill>
+                <a:latin typeface="Calibri"/>
+              </a:defRPr>
+            </a:pPr>
+            <a:r>
+              <a:t>UNIT 1</a:t>
+            </a:r>
+          </a:p>
+          <a:p>
+            <a:pPr algn="ctr">
+              <a:spcBef>
+                <a:spcPts val="400"/>
+              </a:spcBef>
+              <a:defRPr sz="1600" b="1">
+                <a:solidFill>
+                  <a:srgbClr val="FFFFFF"/>
+                </a:solidFill>
+                <a:latin typeface="Calibri"/>
+              </a:defRPr>
+            </a:pPr>
+            <a:r>
+              <a:t>Asymptotic Analysis</a:t>
+            </a:r>
+          </a:p>
+          <a:p>
+            <a:pPr algn="ctr">
+              <a:spcBef>
+                <a:spcPts val="800"/>
+              </a:spcBef>
+              <a:defRPr sz="1300">
+                <a:solidFill>
+                  <a:srgbClr val="CFD8DC"/>
+                </a:solidFill>
+                <a:latin typeface="Calibri"/>
+              </a:defRPr>
+            </a:pPr>
+            <a:r>
+              <a:t>Big-O, Ω, Θ Notations</a:t>
+            </a:r>
+            <a:br/>
+            <a:r>
+              <a:t>Growth Rate Curves</a:t>
+            </a:r>
+            <a:br/>
+            <a:r>
+              <a:t>Semi-Log Scale Graph</a:t>
+            </a:r>
+          </a:p>
+        </p:txBody>
+      </p:sp>
+      <p:sp>
+        <p:nvSpPr>
+          <p:cNvPr id="9" name="Rounded Rectangle 8"/>
+          <p:cNvSpPr/>
+          <p:nvPr/>
+        </p:nvSpPr>
+        <p:spPr>
+          <a:xfrm>
+            <a:off x="3474720" y="3794760"/>
+            <a:ext cx="2468880" cy="2468880"/>
+          </a:xfrm>
+          <a:prstGeom prst="roundRect">
+            <a:avLst/>
+          </a:prstGeom>
+          <a:solidFill>
+            <a:srgbClr val="283593"/>
+          </a:solidFill>
+          <a:ln w="19050">
+            <a:solidFill>
+              <a:srgbClr val="64B5F6"/>
+            </a:solidFill>
+          </a:ln>
+        </p:spPr>
+        <p:style>
+          <a:lnRef idx="1">
+            <a:schemeClr val="accent1"/>
+          </a:lnRef>
+          <a:fillRef idx="3">
+            <a:schemeClr val="accent1"/>
+          </a:fillRef>
+          <a:effectRef idx="2">
+            <a:schemeClr val="accent1"/>
+          </a:effectRef>
+          <a:fontRef idx="minor">
+            <a:schemeClr val="lt1"/>
+          </a:fontRef>
+        </p:style>
+        <p:txBody>
+          <a:bodyPr rtlCol="0" anchor="ctr" wrap="square"/>
+          <a:lstStyle/>
+          <a:p>
+            <a:pPr algn="ctr">
+              <a:defRPr sz="1400" b="1">
+                <a:solidFill>
+                  <a:srgbClr val="FFD54F"/>
+                </a:solidFill>
+                <a:latin typeface="Calibri"/>
+              </a:defRPr>
+            </a:pPr>
+            <a:r>
+              <a:t>UNIT 2</a:t>
+            </a:r>
+          </a:p>
+          <a:p>
+            <a:pPr algn="ctr">
+              <a:spcBef>
+                <a:spcPts val="400"/>
+              </a:spcBef>
+              <a:defRPr sz="1600" b="1">
+                <a:solidFill>
+                  <a:srgbClr val="FFFFFF"/>
+                </a:solidFill>
+                <a:latin typeface="Calibri"/>
+              </a:defRPr>
+            </a:pPr>
+            <a:r>
+              <a:t>Greedy Job Sequencing</a:t>
+            </a:r>
+          </a:p>
+          <a:p>
+            <a:pPr algn="ctr">
+              <a:spcBef>
+                <a:spcPts val="800"/>
+              </a:spcBef>
+              <a:defRPr sz="1300">
+                <a:solidFill>
+                  <a:srgbClr val="CFD8DC"/>
+                </a:solidFill>
+                <a:latin typeface="Calibri"/>
+              </a:defRPr>
+            </a:pPr>
+            <a:r>
+              <a:t>Deadlines &amp; Profits</a:t>
+            </a:r>
+            <a:br/>
+            <a:r>
+              <a:t>Greedy Optimal Strategy</a:t>
+            </a:r>
+            <a:br/>
+            <a:r>
+              <a:t>Decision Flowchart</a:t>
+            </a:r>
+          </a:p>
+        </p:txBody>
+      </p:sp>
+      <p:sp>
+        <p:nvSpPr>
+          <p:cNvPr id="10" name="Rounded Rectangle 9"/>
+          <p:cNvSpPr/>
+          <p:nvPr/>
+        </p:nvSpPr>
+        <p:spPr>
+          <a:xfrm>
+            <a:off x="6217920" y="3794760"/>
+            <a:ext cx="2468880" cy="2468880"/>
+          </a:xfrm>
+          <a:prstGeom prst="roundRect">
+            <a:avLst/>
+          </a:prstGeom>
+          <a:solidFill>
+            <a:srgbClr val="283593"/>
+          </a:solidFill>
+          <a:ln w="19050">
+            <a:solidFill>
+              <a:srgbClr val="64B5F6"/>
+            </a:solidFill>
+          </a:ln>
+        </p:spPr>
+        <p:style>
+          <a:lnRef idx="1">
+            <a:schemeClr val="accent1"/>
+          </a:lnRef>
+          <a:fillRef idx="3">
+            <a:schemeClr val="accent1"/>
+          </a:fillRef>
+          <a:effectRef idx="2">
+            <a:schemeClr val="accent1"/>
+          </a:effectRef>
+          <a:fontRef idx="minor">
+            <a:schemeClr val="lt1"/>
+          </a:fontRef>
+        </p:style>
+        <p:txBody>
+          <a:bodyPr rtlCol="0" anchor="ctr" wrap="square"/>
+          <a:lstStyle/>
+          <a:p>
+            <a:pPr algn="ctr">
+              <a:defRPr sz="1400" b="1">
+                <a:solidFill>
+                  <a:srgbClr val="FFD54F"/>
+                </a:solidFill>
+                <a:latin typeface="Calibri"/>
+              </a:defRPr>
+            </a:pPr>
+            <a:r>
+              <a:t>UNIT 3</a:t>
+            </a:r>
+          </a:p>
+          <a:p>
+            <a:pPr algn="ctr">
+              <a:spcBef>
+                <a:spcPts val="400"/>
+              </a:spcBef>
+              <a:defRPr sz="1600" b="1">
+                <a:solidFill>
+                  <a:srgbClr val="FFFFFF"/>
+                </a:solidFill>
+                <a:latin typeface="Calibri"/>
+              </a:defRPr>
+            </a:pPr>
+            <a:r>
+              <a:t>0/1 Knapsack Problem</a:t>
+            </a:r>
+          </a:p>
+          <a:p>
+            <a:pPr algn="ctr">
+              <a:spcBef>
+                <a:spcPts val="800"/>
+              </a:spcBef>
+              <a:defRPr sz="1300">
+                <a:solidFill>
+                  <a:srgbClr val="CFD8DC"/>
+                </a:solidFill>
+                <a:latin typeface="Calibri"/>
+              </a:defRPr>
+            </a:pPr>
+            <a:r>
+              <a:t>Dynamic Programming</a:t>
+            </a:r>
+            <a:br/>
+            <a:r>
+              <a:t>Optimal Substructure</a:t>
+            </a:r>
+            <a:br/>
+            <a:r>
+              <a:t>Table State Visualization</a:t>
+            </a:r>
+          </a:p>
+        </p:txBody>
+      </p:sp>
+      <p:sp>
+        <p:nvSpPr>
+          <p:cNvPr id="11" name="Rounded Rectangle 10"/>
+          <p:cNvSpPr/>
+          <p:nvPr/>
+        </p:nvSpPr>
+        <p:spPr>
+          <a:xfrm>
+            <a:off x="8961120" y="3794760"/>
+            <a:ext cx="2468880" cy="2468880"/>
+          </a:xfrm>
+          <a:prstGeom prst="roundRect">
+            <a:avLst/>
+          </a:prstGeom>
+          <a:solidFill>
+            <a:srgbClr val="283593"/>
+          </a:solidFill>
+          <a:ln w="19050">
+            <a:solidFill>
+              <a:srgbClr val="64B5F6"/>
+            </a:solidFill>
+          </a:ln>
+        </p:spPr>
+        <p:style>
+          <a:lnRef idx="1">
+            <a:schemeClr val="accent1"/>
+          </a:lnRef>
+          <a:fillRef idx="3">
+            <a:schemeClr val="accent1"/>
+          </a:fillRef>
+          <a:effectRef idx="2">
+            <a:schemeClr val="accent1"/>
+          </a:effectRef>
+          <a:fontRef idx="minor">
+            <a:schemeClr val="lt1"/>
+          </a:fontRef>
+        </p:style>
+        <p:txBody>
+          <a:bodyPr rtlCol="0" anchor="ctr" wrap="square"/>
+          <a:lstStyle/>
+          <a:p>
+            <a:pPr algn="ctr">
+              <a:defRPr sz="1400" b="1">
+                <a:solidFill>
+                  <a:srgbClr val="FFD54F"/>
+                </a:solidFill>
+                <a:latin typeface="Calibri"/>
+              </a:defRPr>
+            </a:pPr>
+            <a:r>
+              <a:t>UNIT 4</a:t>
+            </a:r>
+          </a:p>
+          <a:p>
+            <a:pPr algn="ctr">
+              <a:spcBef>
+                <a:spcPts val="400"/>
+              </a:spcBef>
+              <a:defRPr sz="1600" b="1">
+                <a:solidFill>
+                  <a:srgbClr val="FFFFFF"/>
+                </a:solidFill>
+                <a:latin typeface="Calibri"/>
+              </a:defRPr>
+            </a:pPr>
+            <a:r>
+              <a:t>Sum of Subsets Problem</a:t>
+            </a:r>
+          </a:p>
+          <a:p>
+            <a:pPr algn="ctr">
+              <a:spcBef>
+                <a:spcPts val="800"/>
+              </a:spcBef>
+              <a:defRPr sz="1300">
+                <a:solidFill>
+                  <a:srgbClr val="CFD8DC"/>
+                </a:solidFill>
+                <a:latin typeface="Calibri"/>
+              </a:defRPr>
+            </a:pPr>
+            <a:r>
+              <a:t>Backtracking Technique</a:t>
+            </a:r>
+            <a:br/>
+            <a:r>
+              <a:t>State Space Search Tree</a:t>
+            </a:r>
+            <a:br/>
+            <a:r>
+              <a:t>Early Branch Pruning</a:t>
             </a:r>
           </a:p>
         </p:txBody>

</xml_diff>